<commit_message>
Add Codespaces requirements slide to kick-off deck
Co-authored-by: Copilot App <223556219+Copilot@users.noreply.github.com>
</commit_message>
<xml_diff>
--- a/docs/kick-off.pptx
+++ b/docs/kick-off.pptx
@@ -11,9 +11,10 @@
     <p:sldId id="259" r:id="rId5"/>
     <p:sldId id="260" r:id="rId6"/>
     <p:sldId id="261" r:id="rId7"/>
+    <p:sldId id="262" r:id="rId8"/>
   </p:sldIdLst>
   <p:notesMasterIdLst>
-    <p:notesMasterId r:id="rId8"/>
+    <p:notesMasterId r:id="rId9"/>
   </p:notesMasterIdLst>
   <p:sldSz cx="9144000" cy="5143500"/>
   <p:notesSz cx="5143500" cy="9144000"/>
@@ -971,6 +972,94 @@
             <a:fld id="{F7021451-1387-4CA6-816F-3879F97B5CBC}" type="slidenum">
               <a:rPr lang="en-US"/>
               <a:t>6</a:t>
+            </a:fld>
+            <a:endParaRPr lang="en-US"/>
+          </a:p>
+        </p:txBody>
+      </p:sp>
+    </p:spTree>
+    <p:extLst>
+      <p:ext uri="{BB962C8B-B14F-4D97-AF65-F5344CB8AC3E}">
+        <p14:creationId xmlns:p14="http://schemas.microsoft.com/office/powerpoint/2010/main" val="1024086991"/>
+      </p:ext>
+    </p:extLst>
+  </p:cSld>
+  <p:clrMapOvr>
+    <a:masterClrMapping/>
+  </p:clrMapOvr>
+</p:notes>
+</file>
+
+<file path=ppt/notesSlides/notesSlide7.xml><?xml version="1.0" encoding="utf-8"?>
+<p:notes xmlns:a="http://schemas.openxmlformats.org/drawingml/2006/main" xmlns:r="http://schemas.openxmlformats.org/officeDocument/2006/relationships" xmlns:p="http://schemas.openxmlformats.org/presentationml/2006/main">
+  <p:cSld>
+    <p:spTree>
+      <p:nvGrpSpPr>
+        <p:cNvPr id="1" name=""/>
+        <p:cNvGrpSpPr/>
+        <p:nvPr/>
+      </p:nvGrpSpPr>
+      <p:grpSpPr>
+        <a:xfrm>
+          <a:off x="0" y="0"/>
+          <a:ext cx="0" cy="0"/>
+          <a:chOff x="0" y="0"/>
+          <a:chExt cx="0" cy="0"/>
+        </a:xfrm>
+      </p:grpSpPr>
+      <p:sp>
+        <p:nvSpPr>
+          <p:cNvPr id="2" name="Slide Image Placeholder 1"/>
+          <p:cNvSpPr>
+            <a:spLocks noGrp="1" noRot="1" noChangeAspect="1"/>
+          </p:cNvSpPr>
+          <p:nvPr>
+            <p:ph type="sldImg"/>
+          </p:nvPr>
+        </p:nvSpPr>
+        <p:spPr/>
+      </p:sp>
+      <p:sp>
+        <p:nvSpPr>
+          <p:cNvPr id="3" name="Notes Placeholder 2"/>
+          <p:cNvSpPr>
+            <a:spLocks noGrp="1"/>
+          </p:cNvSpPr>
+          <p:nvPr>
+            <p:ph type="body" idx="1"/>
+          </p:nvPr>
+        </p:nvSpPr>
+        <p:spPr/>
+        <p:txBody>
+          <a:bodyPr/>
+          <a:lstStyle/>
+          <a:p>
+            <a:r>
+              <a:rPr lang="en-US" dirty="0"/>
+              <a:t/>
+            </a:r>
+            <a:endParaRPr lang="en-US" dirty="0"/>
+          </a:p>
+        </p:txBody>
+      </p:sp>
+      <p:sp>
+        <p:nvSpPr>
+          <p:cNvPr id="4" name="Slide Number Placeholder 3"/>
+          <p:cNvSpPr>
+            <a:spLocks noGrp="1"/>
+          </p:cNvSpPr>
+          <p:nvPr>
+            <p:ph type="sldNum" sz="quarter" idx="10"/>
+          </p:nvPr>
+        </p:nvSpPr>
+        <p:spPr/>
+        <p:txBody>
+          <a:bodyPr/>
+          <a:lstStyle/>
+          <a:p>
+            <a:fld id="{F7021451-1387-4CA6-816F-3879F97B5CBC}" type="slidenum">
+              <a:rPr lang="en-US"/>
+              <a:t>7</a:t>
             </a:fld>
             <a:endParaRPr lang="en-US"/>
           </a:p>
@@ -7136,6 +7225,1170 @@
     <p:bg>
       <p:bgPr>
         <a:solidFill>
+          <a:srgbClr val="F6F8FA"/>
+        </a:solidFill>
+      </p:bgPr>
+    </p:bg>
+    <p:spTree>
+      <p:nvGrpSpPr>
+        <p:cNvPr id="1" name=""/>
+        <p:cNvGrpSpPr/>
+        <p:nvPr/>
+      </p:nvGrpSpPr>
+      <p:grpSpPr>
+        <a:xfrm>
+          <a:off x="0" y="0"/>
+          <a:ext cx="0" cy="0"/>
+          <a:chOff x="0" y="0"/>
+          <a:chExt cx="0" cy="0"/>
+        </a:xfrm>
+      </p:grpSpPr>
+      <p:sp>
+        <p:nvSpPr>
+          <p:cNvPr id="2" name="Text 0"/>
+          <p:cNvSpPr/>
+          <p:nvPr/>
+        </p:nvSpPr>
+        <p:spPr>
+          <a:xfrm>
+            <a:off x="457200" y="274320"/>
+            <a:ext cx="8229600" cy="640080"/>
+          </a:xfrm>
+          <a:prstGeom prst="rect">
+            <a:avLst/>
+          </a:prstGeom>
+          <a:noFill/>
+          <a:ln/>
+        </p:spPr>
+        <p:txBody>
+          <a:bodyPr wrap="square" lIns="0" tIns="0" rIns="0" bIns="0" rtlCol="0" anchor="ctr"/>
+          <a:lstStyle/>
+          <a:p>
+            <a:pPr indent="0" marL="0">
+              <a:buNone/>
+            </a:pPr>
+            <a:r>
+              <a:rPr lang="en-US" sz="3000" b="1" dirty="0">
+                <a:solidFill>
+                  <a:srgbClr val="1F2328"/>
+                </a:solidFill>
+                <a:latin typeface="Trebuchet MS" pitchFamily="34" charset="0"/>
+                <a:ea typeface="Trebuchet MS" pitchFamily="34" charset="-122"/>
+                <a:cs typeface="Trebuchet MS" pitchFamily="34" charset="-120"/>
+              </a:rPr>
+              <a:t>Codespaces route: what must be true</a:t>
+            </a:r>
+            <a:endParaRPr lang="en-US" sz="3000" dirty="0"/>
+          </a:p>
+        </p:txBody>
+      </p:sp>
+      <p:sp>
+        <p:nvSpPr>
+          <p:cNvPr id="3" name="Shape 1"/>
+          <p:cNvSpPr/>
+          <p:nvPr/>
+        </p:nvSpPr>
+        <p:spPr>
+          <a:xfrm>
+            <a:off x="457200" y="914400"/>
+            <a:ext cx="3977640" cy="1463040"/>
+          </a:xfrm>
+          <a:prstGeom prst="rect">
+            <a:avLst/>
+          </a:prstGeom>
+          <a:solidFill>
+            <a:srgbClr val="FFFFFF"/>
+          </a:solidFill>
+          <a:ln w="9525">
+            <a:solidFill>
+              <a:srgbClr val="D0D7DE"/>
+            </a:solidFill>
+            <a:prstDash val="solid"/>
+          </a:ln>
+        </p:spPr>
+      </p:sp>
+      <p:sp>
+        <p:nvSpPr>
+          <p:cNvPr id="4" name="Shape 2"/>
+          <p:cNvSpPr/>
+          <p:nvPr/>
+        </p:nvSpPr>
+        <p:spPr>
+          <a:xfrm>
+            <a:off x="457200" y="914400"/>
+            <a:ext cx="73152" cy="1463040"/>
+          </a:xfrm>
+          <a:prstGeom prst="rect">
+            <a:avLst/>
+          </a:prstGeom>
+          <a:solidFill>
+            <a:srgbClr val="8957E5"/>
+          </a:solidFill>
+          <a:ln w="12700">
+            <a:solidFill>
+              <a:srgbClr val="8957E5"/>
+            </a:solidFill>
+            <a:prstDash val="solid"/>
+          </a:ln>
+        </p:spPr>
+      </p:sp>
+      <p:sp>
+        <p:nvSpPr>
+          <p:cNvPr id="5" name="Shape 3"/>
+          <p:cNvSpPr/>
+          <p:nvPr/>
+        </p:nvSpPr>
+        <p:spPr>
+          <a:xfrm>
+            <a:off x="658368" y="1051560"/>
+            <a:ext cx="384048" cy="384048"/>
+          </a:xfrm>
+          <a:prstGeom prst="ellipse">
+            <a:avLst/>
+          </a:prstGeom>
+          <a:solidFill>
+            <a:srgbClr val="8957E5"/>
+          </a:solidFill>
+          <a:ln w="12700">
+            <a:solidFill>
+              <a:srgbClr val="8957E5"/>
+            </a:solidFill>
+            <a:prstDash val="solid"/>
+          </a:ln>
+        </p:spPr>
+      </p:sp>
+      <p:pic>
+        <p:nvPicPr>
+          <p:cNvPr id="6" name="Image 0" descr="preencoded.png">    </p:cNvPr>
+          <p:cNvPicPr>
+            <a:picLocks noChangeAspect="1"/>
+          </p:cNvPicPr>
+          <p:nvPr/>
+        </p:nvPicPr>
+        <p:blipFill>
+          <a:blip r:embed="rId1"/>
+          <a:stretch>
+            <a:fillRect/>
+          </a:stretch>
+        </p:blipFill>
+        <p:spPr>
+          <a:xfrm>
+            <a:off x="754380" y="1147572"/>
+            <a:ext cx="192024" cy="192024"/>
+          </a:xfrm>
+          <a:prstGeom prst="rect">
+            <a:avLst/>
+          </a:prstGeom>
+        </p:spPr>
+      </p:pic>
+      <p:sp>
+        <p:nvSpPr>
+          <p:cNvPr id="7" name="Text 4"/>
+          <p:cNvSpPr/>
+          <p:nvPr/>
+        </p:nvSpPr>
+        <p:spPr>
+          <a:xfrm>
+            <a:off x="1143000" y="1051560"/>
+            <a:ext cx="3154680" cy="384048"/>
+          </a:xfrm>
+          <a:prstGeom prst="rect">
+            <a:avLst/>
+          </a:prstGeom>
+          <a:noFill/>
+          <a:ln/>
+        </p:spPr>
+        <p:txBody>
+          <a:bodyPr wrap="square" lIns="0" tIns="0" rIns="0" bIns="0" rtlCol="0" anchor="ctr"/>
+          <a:lstStyle/>
+          <a:p>
+            <a:pPr indent="0" marL="0">
+              <a:buNone/>
+            </a:pPr>
+            <a:r>
+              <a:rPr lang="en-US" sz="1350" b="1" dirty="0">
+                <a:solidFill>
+                  <a:srgbClr val="1F2328"/>
+                </a:solidFill>
+                <a:latin typeface="Trebuchet MS" pitchFamily="34" charset="0"/>
+                <a:ea typeface="Trebuchet MS" pitchFamily="34" charset="-122"/>
+                <a:cs typeface="Trebuchet MS" pitchFamily="34" charset="-120"/>
+              </a:rPr>
+              <a:t>Organization &amp; enterprise</a:t>
+            </a:r>
+            <a:endParaRPr lang="en-US" sz="1350" dirty="0"/>
+          </a:p>
+        </p:txBody>
+      </p:sp>
+      <p:sp>
+        <p:nvSpPr>
+          <p:cNvPr id="8" name="Text 5"/>
+          <p:cNvSpPr/>
+          <p:nvPr/>
+        </p:nvSpPr>
+        <p:spPr>
+          <a:xfrm>
+            <a:off x="658368" y="1508760"/>
+            <a:ext cx="3657600" cy="841248"/>
+          </a:xfrm>
+          <a:prstGeom prst="rect">
+            <a:avLst/>
+          </a:prstGeom>
+          <a:noFill/>
+          <a:ln/>
+        </p:spPr>
+        <p:txBody>
+          <a:bodyPr wrap="square" lIns="0" tIns="0" rIns="0" bIns="0" rtlCol="0" anchor="t"/>
+          <a:lstStyle/>
+          <a:p>
+            <a:pPr marL="177800" indent="-177800">
+              <a:spcAft>
+                <a:spcPts val="200"/>
+              </a:spcAft>
+              <a:buSzPct val="100000"/>
+              <a:buChar char="•"/>
+            </a:pPr>
+            <a:r>
+              <a:rPr lang="en-US" sz="1050" dirty="0">
+                <a:solidFill>
+                  <a:srgbClr val="1F2328"/>
+                </a:solidFill>
+                <a:latin typeface="Calibri" pitchFamily="34" charset="0"/>
+                <a:ea typeface="Calibri" pitchFamily="34" charset="-122"/>
+                <a:cs typeface="Calibri" pitchFamily="34" charset="-120"/>
+              </a:rPr>
+              <a:t>Codespaces enabled for attendees' repositories</a:t>
+            </a:r>
+            <a:endParaRPr lang="en-US" sz="1050" dirty="0"/>
+          </a:p>
+          <a:p>
+            <a:pPr marL="177800" indent="-177800">
+              <a:spcAft>
+                <a:spcPts val="200"/>
+              </a:spcAft>
+              <a:buSzPct val="100000"/>
+              <a:buChar char="•"/>
+            </a:pPr>
+            <a:r>
+              <a:rPr lang="en-US" sz="1050" dirty="0">
+                <a:solidFill>
+                  <a:srgbClr val="1F2328"/>
+                </a:solidFill>
+                <a:latin typeface="Calibri" pitchFamily="34" charset="0"/>
+                <a:ea typeface="Calibri" pitchFamily="34" charset="-122"/>
+                <a:cs typeface="Calibri" pitchFamily="34" charset="-120"/>
+              </a:rPr>
+              <a:t>No organization IP allow list: it disables codespace creation</a:t>
+            </a:r>
+            <a:endParaRPr lang="en-US" sz="1050" dirty="0"/>
+          </a:p>
+          <a:p>
+            <a:pPr marL="177800" indent="-177800">
+              <a:spcAft>
+                <a:spcPts val="200"/>
+              </a:spcAft>
+              <a:buSzPct val="100000"/>
+              <a:buChar char="•"/>
+            </a:pPr>
+            <a:r>
+              <a:rPr lang="en-US" sz="1050" dirty="0">
+                <a:solidFill>
+                  <a:srgbClr val="1F2328"/>
+                </a:solidFill>
+                <a:latin typeface="Calibri" pitchFamily="34" charset="0"/>
+                <a:ea typeface="Calibri" pitchFamily="34" charset="-122"/>
+                <a:cs typeface="Calibri" pitchFamily="34" charset="-120"/>
+              </a:rPr>
+              <a:t>2–4 core machines, idle timeout and retention set</a:t>
+            </a:r>
+            <a:endParaRPr lang="en-US" sz="1050" dirty="0"/>
+          </a:p>
+          <a:p>
+            <a:pPr marL="177800" indent="-177800">
+              <a:spcAft>
+                <a:spcPts val="200"/>
+              </a:spcAft>
+              <a:buSzPct val="100000"/>
+              <a:buChar char="•"/>
+            </a:pPr>
+            <a:r>
+              <a:rPr lang="en-US" sz="1050" dirty="0">
+                <a:solidFill>
+                  <a:srgbClr val="1F2328"/>
+                </a:solidFill>
+                <a:latin typeface="Calibri" pitchFamily="34" charset="0"/>
+                <a:ea typeface="Calibri" pitchFamily="34" charset="-122"/>
+                <a:cs typeface="Calibri" pitchFamily="34" charset="-120"/>
+              </a:rPr>
+              <a:t>Forks, template repos and ghcr.io pulls allowed</a:t>
+            </a:r>
+            <a:endParaRPr lang="en-US" sz="1050" dirty="0"/>
+          </a:p>
+        </p:txBody>
+      </p:sp>
+      <p:sp>
+        <p:nvSpPr>
+          <p:cNvPr id="9" name="Shape 6"/>
+          <p:cNvSpPr/>
+          <p:nvPr/>
+        </p:nvSpPr>
+        <p:spPr>
+          <a:xfrm>
+            <a:off x="4709160" y="914400"/>
+            <a:ext cx="3977640" cy="1463040"/>
+          </a:xfrm>
+          <a:prstGeom prst="rect">
+            <a:avLst/>
+          </a:prstGeom>
+          <a:solidFill>
+            <a:srgbClr val="FFFFFF"/>
+          </a:solidFill>
+          <a:ln w="9525">
+            <a:solidFill>
+              <a:srgbClr val="D0D7DE"/>
+            </a:solidFill>
+            <a:prstDash val="solid"/>
+          </a:ln>
+        </p:spPr>
+      </p:sp>
+      <p:sp>
+        <p:nvSpPr>
+          <p:cNvPr id="10" name="Shape 7"/>
+          <p:cNvSpPr/>
+          <p:nvPr/>
+        </p:nvSpPr>
+        <p:spPr>
+          <a:xfrm>
+            <a:off x="4709160" y="914400"/>
+            <a:ext cx="73152" cy="1463040"/>
+          </a:xfrm>
+          <a:prstGeom prst="rect">
+            <a:avLst/>
+          </a:prstGeom>
+          <a:solidFill>
+            <a:srgbClr val="2DA44E"/>
+          </a:solidFill>
+          <a:ln w="12700">
+            <a:solidFill>
+              <a:srgbClr val="2DA44E"/>
+            </a:solidFill>
+            <a:prstDash val="solid"/>
+          </a:ln>
+        </p:spPr>
+      </p:sp>
+      <p:sp>
+        <p:nvSpPr>
+          <p:cNvPr id="11" name="Shape 8"/>
+          <p:cNvSpPr/>
+          <p:nvPr/>
+        </p:nvSpPr>
+        <p:spPr>
+          <a:xfrm>
+            <a:off x="4910328" y="1051560"/>
+            <a:ext cx="384048" cy="384048"/>
+          </a:xfrm>
+          <a:prstGeom prst="ellipse">
+            <a:avLst/>
+          </a:prstGeom>
+          <a:solidFill>
+            <a:srgbClr val="2DA44E"/>
+          </a:solidFill>
+          <a:ln w="12700">
+            <a:solidFill>
+              <a:srgbClr val="2DA44E"/>
+            </a:solidFill>
+            <a:prstDash val="solid"/>
+          </a:ln>
+        </p:spPr>
+      </p:sp>
+      <p:pic>
+        <p:nvPicPr>
+          <p:cNvPr id="12" name="Image 1" descr="preencoded.png">    </p:cNvPr>
+          <p:cNvPicPr>
+            <a:picLocks noChangeAspect="1"/>
+          </p:cNvPicPr>
+          <p:nvPr/>
+        </p:nvPicPr>
+        <p:blipFill>
+          <a:blip r:embed="rId2"/>
+          <a:stretch>
+            <a:fillRect/>
+          </a:stretch>
+        </p:blipFill>
+        <p:spPr>
+          <a:xfrm>
+            <a:off x="5006340" y="1147572"/>
+            <a:ext cx="192024" cy="192024"/>
+          </a:xfrm>
+          <a:prstGeom prst="rect">
+            <a:avLst/>
+          </a:prstGeom>
+        </p:spPr>
+      </p:pic>
+      <p:sp>
+        <p:nvSpPr>
+          <p:cNvPr id="13" name="Text 9"/>
+          <p:cNvSpPr/>
+          <p:nvPr/>
+        </p:nvSpPr>
+        <p:spPr>
+          <a:xfrm>
+            <a:off x="5394960" y="1051560"/>
+            <a:ext cx="3154680" cy="384048"/>
+          </a:xfrm>
+          <a:prstGeom prst="rect">
+            <a:avLst/>
+          </a:prstGeom>
+          <a:noFill/>
+          <a:ln/>
+        </p:spPr>
+        <p:txBody>
+          <a:bodyPr wrap="square" lIns="0" tIns="0" rIns="0" bIns="0" rtlCol="0" anchor="ctr"/>
+          <a:lstStyle/>
+          <a:p>
+            <a:pPr indent="0" marL="0">
+              <a:buNone/>
+            </a:pPr>
+            <a:r>
+              <a:rPr lang="en-US" sz="1350" b="1" dirty="0">
+                <a:solidFill>
+                  <a:srgbClr val="1F2328"/>
+                </a:solidFill>
+                <a:latin typeface="Trebuchet MS" pitchFamily="34" charset="0"/>
+                <a:ea typeface="Trebuchet MS" pitchFamily="34" charset="-122"/>
+                <a:cs typeface="Trebuchet MS" pitchFamily="34" charset="-120"/>
+              </a:rPr>
+              <a:t>Billing &amp; budgets</a:t>
+            </a:r>
+            <a:endParaRPr lang="en-US" sz="1350" dirty="0"/>
+          </a:p>
+        </p:txBody>
+      </p:sp>
+      <p:sp>
+        <p:nvSpPr>
+          <p:cNvPr id="14" name="Text 10"/>
+          <p:cNvSpPr/>
+          <p:nvPr/>
+        </p:nvSpPr>
+        <p:spPr>
+          <a:xfrm>
+            <a:off x="4910328" y="1508760"/>
+            <a:ext cx="3657600" cy="841248"/>
+          </a:xfrm>
+          <a:prstGeom prst="rect">
+            <a:avLst/>
+          </a:prstGeom>
+          <a:noFill/>
+          <a:ln/>
+        </p:spPr>
+        <p:txBody>
+          <a:bodyPr wrap="square" lIns="0" tIns="0" rIns="0" bIns="0" rtlCol="0" anchor="t"/>
+          <a:lstStyle/>
+          <a:p>
+            <a:pPr marL="177800" indent="-177800">
+              <a:spcAft>
+                <a:spcPts val="200"/>
+              </a:spcAft>
+              <a:buSzPct val="100000"/>
+              <a:buChar char="•"/>
+            </a:pPr>
+            <a:r>
+              <a:rPr lang="en-US" sz="1050" dirty="0">
+                <a:solidFill>
+                  <a:srgbClr val="1F2328"/>
+                </a:solidFill>
+                <a:latin typeface="Calibri" pitchFamily="34" charset="0"/>
+                <a:ea typeface="Calibri" pitchFamily="34" charset="-122"/>
+                <a:cs typeface="Calibri" pitchFamily="34" charset="-120"/>
+              </a:rPr>
+              <a:t>Billing owner chosen: organization or user</a:t>
+            </a:r>
+            <a:endParaRPr lang="en-US" sz="1050" dirty="0"/>
+          </a:p>
+          <a:p>
+            <a:pPr marL="177800" indent="-177800">
+              <a:spcAft>
+                <a:spcPts val="200"/>
+              </a:spcAft>
+              <a:buSzPct val="100000"/>
+              <a:buChar char="•"/>
+            </a:pPr>
+            <a:r>
+              <a:rPr lang="en-US" sz="1050" dirty="0">
+                <a:solidFill>
+                  <a:srgbClr val="1F2328"/>
+                </a:solidFill>
+                <a:latin typeface="Calibri" pitchFamily="34" charset="0"/>
+                <a:ea typeface="Calibri" pitchFamily="34" charset="-122"/>
+                <a:cs typeface="Calibri" pitchFamily="34" charset="-120"/>
+              </a:rPr>
+              <a:t>Codespaces spending limit above zero</a:t>
+            </a:r>
+            <a:endParaRPr lang="en-US" sz="1050" dirty="0"/>
+          </a:p>
+          <a:p>
+            <a:pPr marL="177800" indent="-177800">
+              <a:spcAft>
+                <a:spcPts val="200"/>
+              </a:spcAft>
+              <a:buSzPct val="100000"/>
+              <a:buChar char="•"/>
+            </a:pPr>
+            <a:r>
+              <a:rPr lang="en-US" sz="1050" dirty="0">
+                <a:solidFill>
+                  <a:srgbClr val="1F2328"/>
+                </a:solidFill>
+                <a:latin typeface="Calibri" pitchFamily="34" charset="0"/>
+                <a:ea typeface="Calibri" pitchFamily="34" charset="-122"/>
+                <a:cs typeface="Calibri" pitchFamily="34" charset="-120"/>
+              </a:rPr>
+              <a:t>Copilot, Actions, Codespaces: separate usage units</a:t>
+            </a:r>
+            <a:endParaRPr lang="en-US" sz="1050" dirty="0"/>
+          </a:p>
+          <a:p>
+            <a:pPr marL="177800" indent="-177800">
+              <a:spcAft>
+                <a:spcPts val="200"/>
+              </a:spcAft>
+              <a:buSzPct val="100000"/>
+              <a:buChar char="•"/>
+            </a:pPr>
+            <a:r>
+              <a:rPr lang="en-US" sz="1050" dirty="0">
+                <a:solidFill>
+                  <a:srgbClr val="1F2328"/>
+                </a:solidFill>
+                <a:latin typeface="Calibri" pitchFamily="34" charset="0"/>
+                <a:ea typeface="Calibri" pitchFamily="34" charset="-122"/>
+                <a:cs typeface="Calibri" pitchFamily="34" charset="-120"/>
+              </a:rPr>
+              <a:t>Prices: see official GitHub billing docs</a:t>
+            </a:r>
+            <a:endParaRPr lang="en-US" sz="1050" dirty="0"/>
+          </a:p>
+        </p:txBody>
+      </p:sp>
+      <p:sp>
+        <p:nvSpPr>
+          <p:cNvPr id="15" name="Shape 11"/>
+          <p:cNvSpPr/>
+          <p:nvPr/>
+        </p:nvSpPr>
+        <p:spPr>
+          <a:xfrm>
+            <a:off x="457200" y="2606040"/>
+            <a:ext cx="3977640" cy="1463040"/>
+          </a:xfrm>
+          <a:prstGeom prst="rect">
+            <a:avLst/>
+          </a:prstGeom>
+          <a:solidFill>
+            <a:srgbClr val="FFFFFF"/>
+          </a:solidFill>
+          <a:ln w="9525">
+            <a:solidFill>
+              <a:srgbClr val="D0D7DE"/>
+            </a:solidFill>
+            <a:prstDash val="solid"/>
+          </a:ln>
+        </p:spPr>
+      </p:sp>
+      <p:sp>
+        <p:nvSpPr>
+          <p:cNvPr id="16" name="Shape 12"/>
+          <p:cNvSpPr/>
+          <p:nvPr/>
+        </p:nvSpPr>
+        <p:spPr>
+          <a:xfrm>
+            <a:off x="457200" y="2606040"/>
+            <a:ext cx="73152" cy="1463040"/>
+          </a:xfrm>
+          <a:prstGeom prst="rect">
+            <a:avLst/>
+          </a:prstGeom>
+          <a:solidFill>
+            <a:srgbClr val="B07D12"/>
+          </a:solidFill>
+          <a:ln w="12700">
+            <a:solidFill>
+              <a:srgbClr val="B07D12"/>
+            </a:solidFill>
+            <a:prstDash val="solid"/>
+          </a:ln>
+        </p:spPr>
+      </p:sp>
+      <p:sp>
+        <p:nvSpPr>
+          <p:cNvPr id="17" name="Shape 13"/>
+          <p:cNvSpPr/>
+          <p:nvPr/>
+        </p:nvSpPr>
+        <p:spPr>
+          <a:xfrm>
+            <a:off x="658368" y="2743200"/>
+            <a:ext cx="384048" cy="384048"/>
+          </a:xfrm>
+          <a:prstGeom prst="ellipse">
+            <a:avLst/>
+          </a:prstGeom>
+          <a:solidFill>
+            <a:srgbClr val="B07D12"/>
+          </a:solidFill>
+          <a:ln w="12700">
+            <a:solidFill>
+              <a:srgbClr val="B07D12"/>
+            </a:solidFill>
+            <a:prstDash val="solid"/>
+          </a:ln>
+        </p:spPr>
+      </p:sp>
+      <p:pic>
+        <p:nvPicPr>
+          <p:cNvPr id="18" name="Image 2" descr="preencoded.png">    </p:cNvPr>
+          <p:cNvPicPr>
+            <a:picLocks noChangeAspect="1"/>
+          </p:cNvPicPr>
+          <p:nvPr/>
+        </p:nvPicPr>
+        <p:blipFill>
+          <a:blip r:embed="rId3"/>
+          <a:stretch>
+            <a:fillRect/>
+          </a:stretch>
+        </p:blipFill>
+        <p:spPr>
+          <a:xfrm>
+            <a:off x="754380" y="2839212"/>
+            <a:ext cx="192024" cy="192024"/>
+          </a:xfrm>
+          <a:prstGeom prst="rect">
+            <a:avLst/>
+          </a:prstGeom>
+        </p:spPr>
+      </p:pic>
+      <p:sp>
+        <p:nvSpPr>
+          <p:cNvPr id="19" name="Text 14"/>
+          <p:cNvSpPr/>
+          <p:nvPr/>
+        </p:nvSpPr>
+        <p:spPr>
+          <a:xfrm>
+            <a:off x="1143000" y="2743200"/>
+            <a:ext cx="3154680" cy="384048"/>
+          </a:xfrm>
+          <a:prstGeom prst="rect">
+            <a:avLst/>
+          </a:prstGeom>
+          <a:noFill/>
+          <a:ln/>
+        </p:spPr>
+        <p:txBody>
+          <a:bodyPr wrap="square" lIns="0" tIns="0" rIns="0" bIns="0" rtlCol="0" anchor="ctr"/>
+          <a:lstStyle/>
+          <a:p>
+            <a:pPr indent="0" marL="0">
+              <a:buNone/>
+            </a:pPr>
+            <a:r>
+              <a:rPr lang="en-US" sz="1350" b="1" dirty="0">
+                <a:solidFill>
+                  <a:srgbClr val="1F2328"/>
+                </a:solidFill>
+                <a:latin typeface="Trebuchet MS" pitchFamily="34" charset="0"/>
+                <a:ea typeface="Trebuchet MS" pitchFamily="34" charset="-122"/>
+                <a:cs typeface="Trebuchet MS" pitchFamily="34" charset="-120"/>
+              </a:rPr>
+              <a:t>Network: attendee workstation only</a:t>
+            </a:r>
+            <a:endParaRPr lang="en-US" sz="1350" dirty="0"/>
+          </a:p>
+        </p:txBody>
+      </p:sp>
+      <p:sp>
+        <p:nvSpPr>
+          <p:cNvPr id="20" name="Text 15"/>
+          <p:cNvSpPr/>
+          <p:nvPr/>
+        </p:nvSpPr>
+        <p:spPr>
+          <a:xfrm>
+            <a:off x="658368" y="3200400"/>
+            <a:ext cx="3657600" cy="841248"/>
+          </a:xfrm>
+          <a:prstGeom prst="rect">
+            <a:avLst/>
+          </a:prstGeom>
+          <a:noFill/>
+          <a:ln/>
+        </p:spPr>
+        <p:txBody>
+          <a:bodyPr wrap="square" lIns="0" tIns="0" rIns="0" bIns="0" rtlCol="0" anchor="t"/>
+          <a:lstStyle/>
+          <a:p>
+            <a:pPr marL="177800" indent="-177800">
+              <a:spcAft>
+                <a:spcPts val="200"/>
+              </a:spcAft>
+              <a:buSzPct val="100000"/>
+              <a:buChar char="•"/>
+            </a:pPr>
+            <a:r>
+              <a:rPr lang="en-US" sz="1050" dirty="0">
+                <a:solidFill>
+                  <a:srgbClr val="1F2328"/>
+                </a:solidFill>
+                <a:latin typeface="Calibri" pitchFamily="34" charset="0"/>
+                <a:ea typeface="Calibri" pitchFamily="34" charset="-122"/>
+                <a:cs typeface="Calibri" pitchFamily="34" charset="-120"/>
+              </a:rPr>
+              <a:t>Allow gh api meta --jq '.domains.codespaces'</a:t>
+            </a:r>
+            <a:endParaRPr lang="en-US" sz="1050" dirty="0"/>
+          </a:p>
+          <a:p>
+            <a:pPr marL="177800" indent="-177800">
+              <a:spcAft>
+                <a:spcPts val="200"/>
+              </a:spcAft>
+              <a:buSzPct val="100000"/>
+              <a:buChar char="•"/>
+            </a:pPr>
+            <a:r>
+              <a:rPr lang="en-US" sz="1050" dirty="0">
+                <a:solidFill>
+                  <a:srgbClr val="1F2328"/>
+                </a:solidFill>
+                <a:latin typeface="Calibri" pitchFamily="34" charset="0"/>
+                <a:ea typeface="Calibri" pitchFamily="34" charset="-122"/>
+                <a:cs typeface="Calibri" pitchFamily="34" charset="-120"/>
+              </a:rPr>
+              <a:t>Allow .domains.website + .domains.copilot (Copilot)</a:t>
+            </a:r>
+            <a:endParaRPr lang="en-US" sz="1050" dirty="0"/>
+          </a:p>
+          <a:p>
+            <a:pPr marL="177800" indent="-177800">
+              <a:spcAft>
+                <a:spcPts val="200"/>
+              </a:spcAft>
+              <a:buSzPct val="100000"/>
+              <a:buChar char="•"/>
+            </a:pPr>
+            <a:r>
+              <a:rPr lang="en-US" sz="1050" dirty="0">
+                <a:solidFill>
+                  <a:srgbClr val="1F2328"/>
+                </a:solidFill>
+                <a:latin typeface="Calibri" pitchFamily="34" charset="0"/>
+                <a:ea typeface="Calibri" pitchFamily="34" charset="-122"/>
+                <a:cs typeface="Calibri" pitchFamily="34" charset="-120"/>
+              </a:rPr>
+              <a:t>WebSockets on, no TLS inspection on *.github.dev</a:t>
+            </a:r>
+            <a:endParaRPr lang="en-US" sz="1050" dirty="0"/>
+          </a:p>
+          <a:p>
+            <a:pPr marL="177800" indent="-177800">
+              <a:spcAft>
+                <a:spcPts val="200"/>
+              </a:spcAft>
+              <a:buSzPct val="100000"/>
+              <a:buChar char="•"/>
+            </a:pPr>
+            <a:r>
+              <a:rPr lang="en-US" sz="1050" dirty="0">
+                <a:solidFill>
+                  <a:srgbClr val="1F2328"/>
+                </a:solidFill>
+                <a:latin typeface="Calibri" pitchFamily="34" charset="0"/>
+                <a:ea typeface="Calibri" pitchFamily="34" charset="-122"/>
+                <a:cs typeface="Calibri" pitchFamily="34" charset="-120"/>
+              </a:rPr>
+              <a:t>Codespace outbound is open: no extra rules</a:t>
+            </a:r>
+            <a:endParaRPr lang="en-US" sz="1050" dirty="0"/>
+          </a:p>
+        </p:txBody>
+      </p:sp>
+      <p:sp>
+        <p:nvSpPr>
+          <p:cNvPr id="21" name="Shape 16"/>
+          <p:cNvSpPr/>
+          <p:nvPr/>
+        </p:nvSpPr>
+        <p:spPr>
+          <a:xfrm>
+            <a:off x="4709160" y="2606040"/>
+            <a:ext cx="3977640" cy="1463040"/>
+          </a:xfrm>
+          <a:prstGeom prst="rect">
+            <a:avLst/>
+          </a:prstGeom>
+          <a:solidFill>
+            <a:srgbClr val="FFFFFF"/>
+          </a:solidFill>
+          <a:ln w="9525">
+            <a:solidFill>
+              <a:srgbClr val="D0D7DE"/>
+            </a:solidFill>
+            <a:prstDash val="solid"/>
+          </a:ln>
+        </p:spPr>
+      </p:sp>
+      <p:sp>
+        <p:nvSpPr>
+          <p:cNvPr id="22" name="Shape 17"/>
+          <p:cNvSpPr/>
+          <p:nvPr/>
+        </p:nvSpPr>
+        <p:spPr>
+          <a:xfrm>
+            <a:off x="4709160" y="2606040"/>
+            <a:ext cx="73152" cy="1463040"/>
+          </a:xfrm>
+          <a:prstGeom prst="rect">
+            <a:avLst/>
+          </a:prstGeom>
+          <a:solidFill>
+            <a:srgbClr val="0969DA"/>
+          </a:solidFill>
+          <a:ln w="12700">
+            <a:solidFill>
+              <a:srgbClr val="0969DA"/>
+            </a:solidFill>
+            <a:prstDash val="solid"/>
+          </a:ln>
+        </p:spPr>
+      </p:sp>
+      <p:sp>
+        <p:nvSpPr>
+          <p:cNvPr id="23" name="Shape 18"/>
+          <p:cNvSpPr/>
+          <p:nvPr/>
+        </p:nvSpPr>
+        <p:spPr>
+          <a:xfrm>
+            <a:off x="4910328" y="2743200"/>
+            <a:ext cx="384048" cy="384048"/>
+          </a:xfrm>
+          <a:prstGeom prst="ellipse">
+            <a:avLst/>
+          </a:prstGeom>
+          <a:solidFill>
+            <a:srgbClr val="0969DA"/>
+          </a:solidFill>
+          <a:ln w="12700">
+            <a:solidFill>
+              <a:srgbClr val="0969DA"/>
+            </a:solidFill>
+            <a:prstDash val="solid"/>
+          </a:ln>
+        </p:spPr>
+      </p:sp>
+      <p:pic>
+        <p:nvPicPr>
+          <p:cNvPr id="24" name="Image 3" descr="preencoded.png">    </p:cNvPr>
+          <p:cNvPicPr>
+            <a:picLocks noChangeAspect="1"/>
+          </p:cNvPicPr>
+          <p:nvPr/>
+        </p:nvPicPr>
+        <p:blipFill>
+          <a:blip r:embed="rId4"/>
+          <a:stretch>
+            <a:fillRect/>
+          </a:stretch>
+        </p:blipFill>
+        <p:spPr>
+          <a:xfrm>
+            <a:off x="5006340" y="2839212"/>
+            <a:ext cx="192024" cy="192024"/>
+          </a:xfrm>
+          <a:prstGeom prst="rect">
+            <a:avLst/>
+          </a:prstGeom>
+        </p:spPr>
+      </p:pic>
+      <p:sp>
+        <p:nvSpPr>
+          <p:cNvPr id="25" name="Text 19"/>
+          <p:cNvSpPr/>
+          <p:nvPr/>
+        </p:nvSpPr>
+        <p:spPr>
+          <a:xfrm>
+            <a:off x="5394960" y="2743200"/>
+            <a:ext cx="3154680" cy="384048"/>
+          </a:xfrm>
+          <a:prstGeom prst="rect">
+            <a:avLst/>
+          </a:prstGeom>
+          <a:noFill/>
+          <a:ln/>
+        </p:spPr>
+        <p:txBody>
+          <a:bodyPr wrap="square" lIns="0" tIns="0" rIns="0" bIns="0" rtlCol="0" anchor="ctr"/>
+          <a:lstStyle/>
+          <a:p>
+            <a:pPr indent="0" marL="0">
+              <a:buNone/>
+            </a:pPr>
+            <a:r>
+              <a:rPr lang="en-US" sz="1350" b="1" dirty="0">
+                <a:solidFill>
+                  <a:srgbClr val="1F2328"/>
+                </a:solidFill>
+                <a:latin typeface="Trebuchet MS" pitchFamily="34" charset="0"/>
+                <a:ea typeface="Trebuchet MS" pitchFamily="34" charset="-122"/>
+                <a:cs typeface="Trebuchet MS" pitchFamily="34" charset="-120"/>
+              </a:rPr>
+              <a:t>Attendee dry run (D-7, D-1)</a:t>
+            </a:r>
+            <a:endParaRPr lang="en-US" sz="1350" dirty="0"/>
+          </a:p>
+        </p:txBody>
+      </p:sp>
+      <p:sp>
+        <p:nvSpPr>
+          <p:cNvPr id="26" name="Text 20"/>
+          <p:cNvSpPr/>
+          <p:nvPr/>
+        </p:nvSpPr>
+        <p:spPr>
+          <a:xfrm>
+            <a:off x="4910328" y="3200400"/>
+            <a:ext cx="3657600" cy="841248"/>
+          </a:xfrm>
+          <a:prstGeom prst="rect">
+            <a:avLst/>
+          </a:prstGeom>
+          <a:noFill/>
+          <a:ln/>
+        </p:spPr>
+        <p:txBody>
+          <a:bodyPr wrap="square" lIns="0" tIns="0" rIns="0" bIns="0" rtlCol="0" anchor="t"/>
+          <a:lstStyle/>
+          <a:p>
+            <a:pPr marL="177800" indent="-177800">
+              <a:spcAft>
+                <a:spcPts val="200"/>
+              </a:spcAft>
+              <a:buSzPct val="100000"/>
+              <a:buChar char="•"/>
+            </a:pPr>
+            <a:r>
+              <a:rPr lang="en-US" sz="1050" dirty="0">
+                <a:solidFill>
+                  <a:srgbClr val="1F2328"/>
+                </a:solidFill>
+                <a:latin typeface="Calibri" pitchFamily="34" charset="0"/>
+                <a:ea typeface="Calibri" pitchFamily="34" charset="-122"/>
+                <a:cs typeface="Calibri" pitchFamily="34" charset="-120"/>
+              </a:rPr>
+              <a:t>Seat visible at github.com/settings/copilot</a:t>
+            </a:r>
+            <a:endParaRPr lang="en-US" sz="1050" dirty="0"/>
+          </a:p>
+          <a:p>
+            <a:pPr marL="177800" indent="-177800">
+              <a:spcAft>
+                <a:spcPts val="200"/>
+              </a:spcAft>
+              <a:buSzPct val="100000"/>
+              <a:buChar char="•"/>
+            </a:pPr>
+            <a:r>
+              <a:rPr lang="en-US" sz="1050" dirty="0">
+                <a:solidFill>
+                  <a:srgbClr val="1F2328"/>
+                </a:solidFill>
+                <a:latin typeface="Calibri" pitchFamily="34" charset="0"/>
+                <a:ea typeface="Calibri" pitchFamily="34" charset="-122"/>
+                <a:cs typeface="Calibri" pitchFamily="34" charset="-120"/>
+              </a:rPr>
+              <a:t>Codespace opens in the browser and in VS Code desktop</a:t>
+            </a:r>
+            <a:endParaRPr lang="en-US" sz="1050" dirty="0"/>
+          </a:p>
+          <a:p>
+            <a:pPr marL="177800" indent="-177800">
+              <a:spcAft>
+                <a:spcPts val="200"/>
+              </a:spcAft>
+              <a:buSzPct val="100000"/>
+              <a:buChar char="•"/>
+            </a:pPr>
+            <a:r>
+              <a:rPr lang="en-US" sz="1050" dirty="0">
+                <a:solidFill>
+                  <a:srgbClr val="1F2328"/>
+                </a:solidFill>
+                <a:latin typeface="Calibri" pitchFamily="34" charset="0"/>
+                <a:ea typeface="Calibri" pitchFamily="34" charset="-122"/>
+                <a:cs typeface="Calibri" pitchFamily="34" charset="-120"/>
+              </a:rPr>
+              <a:t>Tunnel reachable: global.rel.tunnels.api.visualstudio.com</a:t>
+            </a:r>
+            <a:endParaRPr lang="en-US" sz="1050" dirty="0"/>
+          </a:p>
+          <a:p>
+            <a:pPr marL="177800" indent="-177800">
+              <a:spcAft>
+                <a:spcPts val="200"/>
+              </a:spcAft>
+              <a:buSzPct val="100000"/>
+              <a:buChar char="•"/>
+            </a:pPr>
+            <a:r>
+              <a:rPr lang="en-US" sz="1050" dirty="0">
+                <a:solidFill>
+                  <a:srgbClr val="1F2328"/>
+                </a:solidFill>
+                <a:latin typeface="Calibri" pitchFamily="34" charset="0"/>
+                <a:ea typeface="Calibri" pitchFamily="34" charset="-122"/>
+                <a:cs typeface="Calibri" pitchFamily="34" charset="-120"/>
+              </a:rPr>
+              <a:t>D-1: gh auth refresh --scopes workflow</a:t>
+            </a:r>
+            <a:endParaRPr lang="en-US" sz="1050" dirty="0"/>
+          </a:p>
+        </p:txBody>
+      </p:sp>
+      <p:sp>
+        <p:nvSpPr>
+          <p:cNvPr id="27" name="Shape 21"/>
+          <p:cNvSpPr/>
+          <p:nvPr/>
+        </p:nvSpPr>
+        <p:spPr>
+          <a:xfrm>
+            <a:off x="457200" y="4270248"/>
+            <a:ext cx="8229600" cy="329184"/>
+          </a:xfrm>
+          <a:prstGeom prst="rect">
+            <a:avLst/>
+          </a:prstGeom>
+          <a:solidFill>
+            <a:srgbClr val="E9DEFC"/>
+          </a:solidFill>
+          <a:ln w="12700">
+            <a:solidFill>
+              <a:srgbClr val="E9DEFC"/>
+            </a:solidFill>
+            <a:prstDash val="solid"/>
+          </a:ln>
+        </p:spPr>
+      </p:sp>
+      <p:sp>
+        <p:nvSpPr>
+          <p:cNvPr id="28" name="Text 22"/>
+          <p:cNvSpPr/>
+          <p:nvPr/>
+        </p:nvSpPr>
+        <p:spPr>
+          <a:xfrm>
+            <a:off x="594360" y="4270248"/>
+            <a:ext cx="8001000" cy="329184"/>
+          </a:xfrm>
+          <a:prstGeom prst="rect">
+            <a:avLst/>
+          </a:prstGeom>
+          <a:noFill/>
+          <a:ln/>
+        </p:spPr>
+        <p:txBody>
+          <a:bodyPr wrap="square" lIns="0" tIns="0" rIns="0" bIns="0" rtlCol="0" anchor="ctr"/>
+          <a:lstStyle/>
+          <a:p>
+            <a:pPr indent="0" marL="0">
+              <a:buNone/>
+            </a:pPr>
+            <a:r>
+              <a:rPr lang="en-US" sz="1150" b="1" dirty="0">
+                <a:solidFill>
+                  <a:srgbClr val="8957E5"/>
+                </a:solidFill>
+                <a:latin typeface="Calibri" pitchFamily="34" charset="0"/>
+                <a:ea typeface="Calibri" pitchFamily="34" charset="-122"/>
+                <a:cs typeface="Calibri" pitchFamily="34" charset="-120"/>
+              </a:rPr>
+              <a:t>Blocked?  </a:t>
+            </a:r>
+            <a:pPr indent="0" marL="0">
+              <a:buNone/>
+            </a:pPr>
+            <a:r>
+              <a:rPr lang="en-US" sz="1150" dirty="0">
+                <a:solidFill>
+                  <a:srgbClr val="1F2328"/>
+                </a:solidFill>
+                <a:latin typeface="Calibri" pitchFamily="34" charset="0"/>
+                <a:ea typeface="Calibri" pitchFamily="34" charset="-122"/>
+                <a:cs typeface="Calibri" pitchFamily="34" charset="-120"/>
+              </a:rPr>
+              <a:t>IP allow list or rules that cannot change → switch to the local dev container (docs/before-d-day-devcontainer.md)</a:t>
+            </a:r>
+            <a:endParaRPr lang="en-US" sz="1150" dirty="0"/>
+          </a:p>
+        </p:txBody>
+      </p:sp>
+      <p:sp>
+        <p:nvSpPr>
+          <p:cNvPr id="29" name="Text 23"/>
+          <p:cNvSpPr/>
+          <p:nvPr/>
+        </p:nvSpPr>
+        <p:spPr>
+          <a:xfrm>
+            <a:off x="457200" y="4681728"/>
+            <a:ext cx="8229600" cy="274320"/>
+          </a:xfrm>
+          <a:prstGeom prst="rect">
+            <a:avLst/>
+          </a:prstGeom>
+          <a:noFill/>
+          <a:ln/>
+        </p:spPr>
+        <p:txBody>
+          <a:bodyPr wrap="square" lIns="0" tIns="0" rIns="0" bIns="0" rtlCol="0" anchor="ctr"/>
+          <a:lstStyle/>
+          <a:p>
+            <a:pPr algn="r" indent="0" marL="0">
+              <a:buNone/>
+            </a:pPr>
+            <a:r>
+              <a:rPr lang="en-US" sz="1000" dirty="0">
+                <a:solidFill>
+                  <a:srgbClr val="59636E"/>
+                </a:solidFill>
+                <a:latin typeface="Calibri" pitchFamily="34" charset="0"/>
+                <a:ea typeface="Calibri" pitchFamily="34" charset="-122"/>
+                <a:cs typeface="Calibri" pitchFamily="34" charset="-120"/>
+              </a:rPr>
+              <a:t>Agentic SDLC with GitHub Copilot · Kick-off  |  6</a:t>
+            </a:r>
+            <a:endParaRPr lang="en-US" sz="1000" dirty="0"/>
+          </a:p>
+        </p:txBody>
+      </p:sp>
+    </p:spTree>
+  </p:cSld>
+  <p:clrMapOvr>
+    <a:masterClrMapping/>
+  </p:clrMapOvr>
+</p:sld>
+</file>
+
+<file path=ppt/slides/slide7.xml><?xml version="1.0" encoding="utf-8"?>
+<p:sld xmlns:a="http://schemas.openxmlformats.org/drawingml/2006/main" xmlns:r="http://schemas.openxmlformats.org/officeDocument/2006/relationships" xmlns:p="http://schemas.openxmlformats.org/presentationml/2006/main">
+  <p:cSld name="Slide 7">
+    <p:bg>
+      <p:bgPr>
+        <a:solidFill>
           <a:srgbClr val="0D1117"/>
         </a:solidFill>
       </p:bgPr>
@@ -7352,7 +8605,7 @@
           <a:bodyPr wrap="square" lIns="0" tIns="0" rIns="0" bIns="0" rtlCol="0" anchor="t"/>
           <a:lstStyle/>
           <a:p>
-            <a:pPr marL="342900" indent="-342900">
+            <a:pPr marL="177800" indent="-177800">
               <a:spcAft>
                 <a:spcPts val="500"/>
               </a:spcAft>
@@ -7373,7 +8626,7 @@
             <a:endParaRPr lang="en-US" sz="1100" dirty="0"/>
           </a:p>
           <a:p>
-            <a:pPr marL="342900" indent="-342900">
+            <a:pPr marL="177800" indent="-177800">
               <a:spcAft>
                 <a:spcPts val="500"/>
               </a:spcAft>
@@ -7394,7 +8647,7 @@
             <a:endParaRPr lang="en-US" sz="1100" dirty="0"/>
           </a:p>
           <a:p>
-            <a:pPr marL="342900" indent="-342900">
+            <a:pPr marL="177800" indent="-177800">
               <a:spcAft>
                 <a:spcPts val="500"/>
               </a:spcAft>
@@ -7415,7 +8668,7 @@
             <a:endParaRPr lang="en-US" sz="1100" dirty="0"/>
           </a:p>
           <a:p>
-            <a:pPr marL="342900" indent="-342900">
+            <a:pPr marL="177800" indent="-177800">
               <a:spcAft>
                 <a:spcPts val="500"/>
               </a:spcAft>
@@ -7436,7 +8689,7 @@
             <a:endParaRPr lang="en-US" sz="1100" dirty="0"/>
           </a:p>
           <a:p>
-            <a:pPr marL="342900" indent="-342900">
+            <a:pPr marL="177800" indent="-177800">
               <a:spcAft>
                 <a:spcPts val="500"/>
               </a:spcAft>
@@ -7617,7 +8870,7 @@
           <a:bodyPr wrap="square" lIns="0" tIns="0" rIns="0" bIns="0" rtlCol="0" anchor="t"/>
           <a:lstStyle/>
           <a:p>
-            <a:pPr marL="342900" indent="-342900">
+            <a:pPr marL="177800" indent="-177800">
               <a:spcAft>
                 <a:spcPts val="500"/>
               </a:spcAft>
@@ -7638,7 +8891,7 @@
             <a:endParaRPr lang="en-US" sz="1100" dirty="0"/>
           </a:p>
           <a:p>
-            <a:pPr marL="342900" indent="-342900">
+            <a:pPr marL="177800" indent="-177800">
               <a:spcAft>
                 <a:spcPts val="500"/>
               </a:spcAft>
@@ -7659,7 +8912,7 @@
             <a:endParaRPr lang="en-US" sz="1100" dirty="0"/>
           </a:p>
           <a:p>
-            <a:pPr marL="342900" indent="-342900">
+            <a:pPr marL="177800" indent="-177800">
               <a:spcAft>
                 <a:spcPts val="500"/>
               </a:spcAft>
@@ -7680,7 +8933,7 @@
             <a:endParaRPr lang="en-US" sz="1100" dirty="0"/>
           </a:p>
           <a:p>
-            <a:pPr marL="342900" indent="-342900">
+            <a:pPr marL="177800" indent="-177800">
               <a:spcAft>
                 <a:spcPts val="500"/>
               </a:spcAft>
@@ -7861,7 +9114,7 @@
           <a:bodyPr wrap="square" lIns="0" tIns="0" rIns="0" bIns="0" rtlCol="0" anchor="t"/>
           <a:lstStyle/>
           <a:p>
-            <a:pPr marL="342900" indent="-342900">
+            <a:pPr marL="177800" indent="-177800">
               <a:spcAft>
                 <a:spcPts val="500"/>
               </a:spcAft>
@@ -7882,7 +9135,7 @@
             <a:endParaRPr lang="en-US" sz="1100" dirty="0"/>
           </a:p>
           <a:p>
-            <a:pPr marL="342900" indent="-342900">
+            <a:pPr marL="177800" indent="-177800">
               <a:spcAft>
                 <a:spcPts val="500"/>
               </a:spcAft>
@@ -7903,7 +9156,7 @@
             <a:endParaRPr lang="en-US" sz="1100" dirty="0"/>
           </a:p>
           <a:p>
-            <a:pPr marL="342900" indent="-342900">
+            <a:pPr marL="177800" indent="-177800">
               <a:spcAft>
                 <a:spcPts val="500"/>
               </a:spcAft>
@@ -7924,7 +9177,7 @@
             <a:endParaRPr lang="en-US" sz="1100" dirty="0"/>
           </a:p>
           <a:p>
-            <a:pPr marL="342900" indent="-342900">
+            <a:pPr marL="177800" indent="-177800">
               <a:spcAft>
                 <a:spcPts val="500"/>
               </a:spcAft>
@@ -8060,7 +9313,7 @@
                 <a:ea typeface="Calibri" pitchFamily="34" charset="-122"/>
                 <a:cs typeface="Calibri" pitchFamily="34" charset="-120"/>
               </a:rPr>
-              <a:t>Agentic SDLC with GitHub Copilot · Kick-off  |  6</a:t>
+              <a:t>Agentic SDLC with GitHub Copilot · Kick-off  |  7</a:t>
             </a:r>
             <a:endParaRPr lang="en-US" sz="1000" dirty="0"/>
           </a:p>

</xml_diff>

<commit_message>
docs: mark Codespaces-only items in kick-off deck and add live-call org checklist
Co-authored-by: Copilot App <223556219+Copilot@users.noreply.github.com>
</commit_message>
<xml_diff>
--- a/docs/kick-off.pptx
+++ b/docs/kick-off.pptx
@@ -7449,10 +7449,15 @@
               <a:buChar char="•"/>
             </a:pPr>
             <a:r>
-              <a:rPr lang="en-US" sz="1050" dirty="0">
-                <a:solidFill>
-                  <a:srgbClr val="1F2328"/>
-                </a:solidFill>
+              <a:rPr lang="en-US" sz="1050" i="1" u="sng" dirty="0">
+                <a:solidFill>
+                  <a:srgbClr val="0969DA"/>
+                </a:solidFill>
+                <a:uFill>
+                  <a:solidFill>
+                    <a:srgbClr val="0969DA"/>
+                  </a:solidFill>
+                </a:uFill>
                 <a:latin typeface="Calibri" pitchFamily="34" charset="0"/>
                 <a:ea typeface="Calibri" pitchFamily="34" charset="-122"/>
                 <a:cs typeface="Calibri" pitchFamily="34" charset="-120"/>
@@ -7470,10 +7475,15 @@
               <a:buChar char="•"/>
             </a:pPr>
             <a:r>
-              <a:rPr lang="en-US" sz="1050" dirty="0">
-                <a:solidFill>
-                  <a:srgbClr val="1F2328"/>
-                </a:solidFill>
+              <a:rPr lang="en-US" sz="1050" i="1" u="sng" dirty="0">
+                <a:solidFill>
+                  <a:srgbClr val="0969DA"/>
+                </a:solidFill>
+                <a:uFill>
+                  <a:solidFill>
+                    <a:srgbClr val="0969DA"/>
+                  </a:solidFill>
+                </a:uFill>
                 <a:latin typeface="Calibri" pitchFamily="34" charset="0"/>
                 <a:ea typeface="Calibri" pitchFamily="34" charset="-122"/>
                 <a:cs typeface="Calibri" pitchFamily="34" charset="-120"/>
@@ -7491,10 +7501,15 @@
               <a:buChar char="•"/>
             </a:pPr>
             <a:r>
-              <a:rPr lang="en-US" sz="1050" dirty="0">
-                <a:solidFill>
-                  <a:srgbClr val="1F2328"/>
-                </a:solidFill>
+              <a:rPr lang="en-US" sz="1050" i="1" u="sng" dirty="0">
+                <a:solidFill>
+                  <a:srgbClr val="0969DA"/>
+                </a:solidFill>
+                <a:uFill>
+                  <a:solidFill>
+                    <a:srgbClr val="0969DA"/>
+                  </a:solidFill>
+                </a:uFill>
                 <a:latin typeface="Calibri" pitchFamily="34" charset="0"/>
                 <a:ea typeface="Calibri" pitchFamily="34" charset="-122"/>
                 <a:cs typeface="Calibri" pitchFamily="34" charset="-120"/>
@@ -7693,15 +7708,20 @@
               <a:buChar char="•"/>
             </a:pPr>
             <a:r>
-              <a:rPr lang="en-US" sz="1050" dirty="0">
-                <a:solidFill>
-                  <a:srgbClr val="1F2328"/>
-                </a:solidFill>
-                <a:latin typeface="Calibri" pitchFamily="34" charset="0"/>
-                <a:ea typeface="Calibri" pitchFamily="34" charset="-122"/>
-                <a:cs typeface="Calibri" pitchFamily="34" charset="-120"/>
-              </a:rPr>
-              <a:t>Billing owner chosen: organization or user</a:t>
+              <a:rPr lang="en-US" sz="1050" i="1" u="sng" dirty="0">
+                <a:solidFill>
+                  <a:srgbClr val="0969DA"/>
+                </a:solidFill>
+                <a:uFill>
+                  <a:solidFill>
+                    <a:srgbClr val="0969DA"/>
+                  </a:solidFill>
+                </a:uFill>
+                <a:latin typeface="Calibri" pitchFamily="34" charset="0"/>
+                <a:ea typeface="Calibri" pitchFamily="34" charset="-122"/>
+                <a:cs typeface="Calibri" pitchFamily="34" charset="-120"/>
+              </a:rPr>
+              <a:t>Codespaces billing owner chosen: organization or user</a:t>
             </a:r>
             <a:endParaRPr lang="en-US" sz="1050" dirty="0"/>
           </a:p>
@@ -7714,10 +7734,15 @@
               <a:buChar char="•"/>
             </a:pPr>
             <a:r>
-              <a:rPr lang="en-US" sz="1050" dirty="0">
-                <a:solidFill>
-                  <a:srgbClr val="1F2328"/>
-                </a:solidFill>
+              <a:rPr lang="en-US" sz="1050" i="1" u="sng" dirty="0">
+                <a:solidFill>
+                  <a:srgbClr val="0969DA"/>
+                </a:solidFill>
+                <a:uFill>
+                  <a:solidFill>
+                    <a:srgbClr val="0969DA"/>
+                  </a:solidFill>
+                </a:uFill>
                 <a:latin typeface="Calibri" pitchFamily="34" charset="0"/>
                 <a:ea typeface="Calibri" pitchFamily="34" charset="-122"/>
                 <a:cs typeface="Calibri" pitchFamily="34" charset="-120"/>
@@ -7937,10 +7962,15 @@
               <a:buChar char="•"/>
             </a:pPr>
             <a:r>
-              <a:rPr lang="en-US" sz="1050" dirty="0">
-                <a:solidFill>
-                  <a:srgbClr val="1F2328"/>
-                </a:solidFill>
+              <a:rPr lang="en-US" sz="1050" i="1" u="sng" dirty="0">
+                <a:solidFill>
+                  <a:srgbClr val="0969DA"/>
+                </a:solidFill>
+                <a:uFill>
+                  <a:solidFill>
+                    <a:srgbClr val="0969DA"/>
+                  </a:solidFill>
+                </a:uFill>
                 <a:latin typeface="Calibri" pitchFamily="34" charset="0"/>
                 <a:ea typeface="Calibri" pitchFamily="34" charset="-122"/>
                 <a:cs typeface="Calibri" pitchFamily="34" charset="-120"/>
@@ -7979,10 +8009,15 @@
               <a:buChar char="•"/>
             </a:pPr>
             <a:r>
-              <a:rPr lang="en-US" sz="1050" dirty="0">
-                <a:solidFill>
-                  <a:srgbClr val="1F2328"/>
-                </a:solidFill>
+              <a:rPr lang="en-US" sz="1050" i="1" u="sng" dirty="0">
+                <a:solidFill>
+                  <a:srgbClr val="0969DA"/>
+                </a:solidFill>
+                <a:uFill>
+                  <a:solidFill>
+                    <a:srgbClr val="0969DA"/>
+                  </a:solidFill>
+                </a:uFill>
                 <a:latin typeface="Calibri" pitchFamily="34" charset="0"/>
                 <a:ea typeface="Calibri" pitchFamily="34" charset="-122"/>
                 <a:cs typeface="Calibri" pitchFamily="34" charset="-120"/>
@@ -8000,10 +8035,15 @@
               <a:buChar char="•"/>
             </a:pPr>
             <a:r>
-              <a:rPr lang="en-US" sz="1050" dirty="0">
-                <a:solidFill>
-                  <a:srgbClr val="1F2328"/>
-                </a:solidFill>
+              <a:rPr lang="en-US" sz="1050" i="1" u="sng" dirty="0">
+                <a:solidFill>
+                  <a:srgbClr val="0969DA"/>
+                </a:solidFill>
+                <a:uFill>
+                  <a:solidFill>
+                    <a:srgbClr val="0969DA"/>
+                  </a:solidFill>
+                </a:uFill>
                 <a:latin typeface="Calibri" pitchFamily="34" charset="0"/>
                 <a:ea typeface="Calibri" pitchFamily="34" charset="-122"/>
                 <a:cs typeface="Calibri" pitchFamily="34" charset="-120"/>
@@ -8202,10 +8242,15 @@
               <a:buChar char="•"/>
             </a:pPr>
             <a:r>
-              <a:rPr lang="en-US" sz="1050" dirty="0">
-                <a:solidFill>
-                  <a:srgbClr val="1F2328"/>
-                </a:solidFill>
+              <a:rPr lang="en-US" sz="1050" i="1" u="sng" dirty="0">
+                <a:solidFill>
+                  <a:srgbClr val="0969DA"/>
+                </a:solidFill>
+                <a:uFill>
+                  <a:solidFill>
+                    <a:srgbClr val="0969DA"/>
+                  </a:solidFill>
+                </a:uFill>
                 <a:latin typeface="Calibri" pitchFamily="34" charset="0"/>
                 <a:ea typeface="Calibri" pitchFamily="34" charset="-122"/>
                 <a:cs typeface="Calibri" pitchFamily="34" charset="-120"/>
@@ -8223,10 +8268,15 @@
               <a:buChar char="•"/>
             </a:pPr>
             <a:r>
-              <a:rPr lang="en-US" sz="1050" dirty="0">
-                <a:solidFill>
-                  <a:srgbClr val="1F2328"/>
-                </a:solidFill>
+              <a:rPr lang="en-US" sz="1050" i="1" u="sng" dirty="0">
+                <a:solidFill>
+                  <a:srgbClr val="0969DA"/>
+                </a:solidFill>
+                <a:uFill>
+                  <a:solidFill>
+                    <a:srgbClr val="0969DA"/>
+                  </a:solidFill>
+                </a:uFill>
                 <a:latin typeface="Calibri" pitchFamily="34" charset="0"/>
                 <a:ea typeface="Calibri" pitchFamily="34" charset="-122"/>
                 <a:cs typeface="Calibri" pitchFamily="34" charset="-120"/>
@@ -8339,6 +8389,64 @@
       <p:sp>
         <p:nvSpPr>
           <p:cNvPr id="29" name="Text 23"/>
+          <p:cNvSpPr/>
+          <p:nvPr/>
+        </p:nvSpPr>
+        <p:spPr>
+          <a:xfrm>
+            <a:off x="457200" y="4700016"/>
+            <a:ext cx="4114800" cy="228600"/>
+          </a:xfrm>
+          <a:prstGeom prst="rect">
+            <a:avLst/>
+          </a:prstGeom>
+          <a:noFill/>
+          <a:ln/>
+        </p:spPr>
+        <p:txBody>
+          <a:bodyPr wrap="square" lIns="0" tIns="0" rIns="0" bIns="0" rtlCol="0" anchor="ctr"/>
+          <a:lstStyle/>
+          <a:p>
+            <a:pPr algn="l" indent="0" marL="0">
+              <a:buNone/>
+            </a:pPr>
+            <a:r>
+              <a:rPr lang="en-US" sz="1000" i="1" u="sng" dirty="0">
+                <a:solidFill>
+                  <a:srgbClr val="0969DA"/>
+                </a:solidFill>
+                <a:uFill>
+                  <a:solidFill>
+                    <a:srgbClr val="0969DA"/>
+                  </a:solidFill>
+                </a:uFill>
+                <a:latin typeface="Calibri" pitchFamily="34" charset="0"/>
+                <a:ea typeface="Calibri" pitchFamily="34" charset="-122"/>
+                <a:cs typeface="Calibri" pitchFamily="34" charset="-120"/>
+              </a:rPr>
+              <a:t>Codespaces route only</a:t>
+            </a:r>
+            <a:pPr algn="l" indent="0" marL="0">
+              <a:buNone/>
+            </a:pPr>
+            <a:r>
+              <a:rPr lang="en-US" sz="1000" dirty="0">
+                <a:solidFill>
+                  <a:srgbClr val="59636E"/>
+                </a:solidFill>
+                <a:latin typeface="Calibri" pitchFamily="34" charset="0"/>
+                <a:ea typeface="Calibri" pitchFamily="34" charset="-122"/>
+                <a:cs typeface="Calibri" pitchFamily="34" charset="-120"/>
+              </a:rPr>
+              <a:t>  ·  plain text = every route</a:t>
+            </a:r>
+            <a:endParaRPr lang="en-US" sz="1000" dirty="0"/>
+          </a:p>
+        </p:txBody>
+      </p:sp>
+      <p:sp>
+        <p:nvSpPr>
+          <p:cNvPr id="30" name="Text 24"/>
           <p:cNvSpPr/>
           <p:nvPr/>
         </p:nvSpPr>
@@ -8899,10 +9007,15 @@
               <a:buChar char="•"/>
             </a:pPr>
             <a:r>
-              <a:rPr lang="en-US" sz="1100" dirty="0">
-                <a:solidFill>
-                  <a:srgbClr val="C9D1D9"/>
-                </a:solidFill>
+              <a:rPr lang="en-US" sz="1100" i="1" u="sng" dirty="0">
+                <a:solidFill>
+                  <a:srgbClr val="79C0FF"/>
+                </a:solidFill>
+                <a:uFill>
+                  <a:solidFill>
+                    <a:srgbClr val="79C0FF"/>
+                  </a:solidFill>
+                </a:uFill>
                 <a:latin typeface="Calibri" pitchFamily="34" charset="0"/>
                 <a:ea typeface="Calibri" pitchFamily="34" charset="-122"/>
                 <a:cs typeface="Calibri" pitchFamily="34" charset="-120"/>
@@ -8920,10 +9033,15 @@
               <a:buChar char="•"/>
             </a:pPr>
             <a:r>
-              <a:rPr lang="en-US" sz="1100" dirty="0">
-                <a:solidFill>
-                  <a:srgbClr val="C9D1D9"/>
-                </a:solidFill>
+              <a:rPr lang="en-US" sz="1100" i="1" u="sng" dirty="0">
+                <a:solidFill>
+                  <a:srgbClr val="79C0FF"/>
+                </a:solidFill>
+                <a:uFill>
+                  <a:solidFill>
+                    <a:srgbClr val="79C0FF"/>
+                  </a:solidFill>
+                </a:uFill>
                 <a:latin typeface="Calibri" pitchFamily="34" charset="0"/>
                 <a:ea typeface="Calibri" pitchFamily="34" charset="-122"/>
                 <a:cs typeface="Calibri" pitchFamily="34" charset="-120"/>
@@ -9122,10 +9240,15 @@
               <a:buChar char="•"/>
             </a:pPr>
             <a:r>
-              <a:rPr lang="en-US" sz="1100" dirty="0">
-                <a:solidFill>
-                  <a:srgbClr val="C9D1D9"/>
-                </a:solidFill>
+              <a:rPr lang="en-US" sz="1100" i="1" u="sng" dirty="0">
+                <a:solidFill>
+                  <a:srgbClr val="79C0FF"/>
+                </a:solidFill>
+                <a:uFill>
+                  <a:solidFill>
+                    <a:srgbClr val="79C0FF"/>
+                  </a:solidFill>
+                </a:uFill>
                 <a:latin typeface="Calibri" pitchFamily="34" charset="0"/>
                 <a:ea typeface="Calibri" pitchFamily="34" charset="-122"/>
                 <a:cs typeface="Calibri" pitchFamily="34" charset="-120"/>
@@ -9172,7 +9295,29 @@
                 <a:ea typeface="Calibri" pitchFamily="34" charset="-122"/>
                 <a:cs typeface="Calibri" pitchFamily="34" charset="-120"/>
               </a:rPr>
-              <a:t>ghcr.io and *.github.dev reachable</a:t>
+              <a:t>ghcr.io reachable; </a:t>
+            </a:r>
+            <a:pPr indent="0" marL="0">
+              <a:spcAft>
+                <a:spcPts val="500"/>
+              </a:spcAft>
+              <a:buNone/>
+            </a:pPr>
+            <a:r>
+              <a:rPr lang="en-US" sz="1100" i="1" u="sng" dirty="0">
+                <a:solidFill>
+                  <a:srgbClr val="79C0FF"/>
+                </a:solidFill>
+                <a:uFill>
+                  <a:solidFill>
+                    <a:srgbClr val="79C0FF"/>
+                  </a:solidFill>
+                </a:uFill>
+                <a:latin typeface="Calibri" pitchFamily="34" charset="0"/>
+                <a:ea typeface="Calibri" pitchFamily="34" charset="-122"/>
+                <a:cs typeface="Calibri" pitchFamily="34" charset="-120"/>
+              </a:rPr>
+              <a:t>*.github.dev reachable</a:t>
             </a:r>
             <a:endParaRPr lang="en-US" sz="1100" dirty="0"/>
           </a:p>
@@ -9283,6 +9428,64 @@
       <p:sp>
         <p:nvSpPr>
           <p:cNvPr id="22" name="Text 17"/>
+          <p:cNvSpPr/>
+          <p:nvPr/>
+        </p:nvSpPr>
+        <p:spPr>
+          <a:xfrm>
+            <a:off x="457200" y="4700016"/>
+            <a:ext cx="4114800" cy="228600"/>
+          </a:xfrm>
+          <a:prstGeom prst="rect">
+            <a:avLst/>
+          </a:prstGeom>
+          <a:noFill/>
+          <a:ln/>
+        </p:spPr>
+        <p:txBody>
+          <a:bodyPr wrap="square" lIns="0" tIns="0" rIns="0" bIns="0" rtlCol="0" anchor="ctr"/>
+          <a:lstStyle/>
+          <a:p>
+            <a:pPr algn="l" indent="0" marL="0">
+              <a:buNone/>
+            </a:pPr>
+            <a:r>
+              <a:rPr lang="en-US" sz="1000" i="1" u="sng" dirty="0">
+                <a:solidFill>
+                  <a:srgbClr val="79C0FF"/>
+                </a:solidFill>
+                <a:uFill>
+                  <a:solidFill>
+                    <a:srgbClr val="79C0FF"/>
+                  </a:solidFill>
+                </a:uFill>
+                <a:latin typeface="Calibri" pitchFamily="34" charset="0"/>
+                <a:ea typeface="Calibri" pitchFamily="34" charset="-122"/>
+                <a:cs typeface="Calibri" pitchFamily="34" charset="-120"/>
+              </a:rPr>
+              <a:t>Codespaces route only</a:t>
+            </a:r>
+            <a:pPr algn="l" indent="0" marL="0">
+              <a:buNone/>
+            </a:pPr>
+            <a:r>
+              <a:rPr lang="en-US" sz="1000" dirty="0">
+                <a:solidFill>
+                  <a:srgbClr val="A8B1BB"/>
+                </a:solidFill>
+                <a:latin typeface="Calibri" pitchFamily="34" charset="0"/>
+                <a:ea typeface="Calibri" pitchFamily="34" charset="-122"/>
+                <a:cs typeface="Calibri" pitchFamily="34" charset="-120"/>
+              </a:rPr>
+              <a:t>  ·  plain text = every route</a:t>
+            </a:r>
+            <a:endParaRPr lang="en-US" sz="1000" dirty="0"/>
+          </a:p>
+        </p:txBody>
+      </p:sp>
+      <p:sp>
+        <p:nvSpPr>
+          <p:cNvPr id="23" name="Text 18"/>
           <p:cNvSpPr/>
           <p:nvPr/>
         </p:nvSpPr>

</xml_diff>